<commit_message>
Update MBSE pipeline executive briefing deck
Co-Authored-By: Claude Opus 4.6 (1M context) <noreply@anthropic.com>
</commit_message>
<xml_diff>
--- a/docs/MBSE_Pipeline_Executive_Brief.pptx
+++ b/docs/MBSE_Pipeline_Executive_Brief.pptx
@@ -8810,7 +8810,7 @@
             </a:avLst>
           </a:prstGeom>
           <a:solidFill>
-            <a:srgbClr val="0069B0"/>
+            <a:srgbClr val="004A87"/>
           </a:solidFill>
           <a:ln>
             <a:noFill/>
@@ -8912,7 +8912,7 @@
             </a:avLst>
           </a:prstGeom>
           <a:solidFill>
-            <a:srgbClr val="003F80"/>
+            <a:srgbClr val="0069B0"/>
           </a:solidFill>
           <a:ln>
             <a:noFill/>
@@ -9516,91 +9516,13 @@
       </p:sp>
       <p:sp>
         <p:nvSpPr>
-          <p:cNvPr id="22" name="TextBox 21"/>
-          <p:cNvSpPr txBox="1"/>
-          <p:nvPr/>
-        </p:nvSpPr>
-        <p:spPr>
-          <a:xfrm>
-            <a:off x="457200" y="4434840"/>
-            <a:ext cx="5500000" cy="274320"/>
-          </a:xfrm>
-          <a:prstGeom prst="rect">
-            <a:avLst/>
-          </a:prstGeom>
-          <a:noFill/>
-        </p:spPr>
-        <p:txBody>
-          <a:bodyPr wrap="square">
-            <a:spAutoFit/>
-          </a:bodyPr>
-          <a:lstStyle/>
-          <a:p>
-            <a:pPr algn="ctr">
-              <a:spcAft>
-                <a:spcPts val="0"/>
-              </a:spcAft>
-              <a:defRPr sz="1100" b="1">
-                <a:solidFill>
-                  <a:srgbClr val="0069B0"/>
-                </a:solidFill>
-                <a:latin typeface="Calibri"/>
-              </a:defRPr>
-            </a:pPr>
-            <a:r>
-              <a:t>REPO 1: cameo-model-pipeline</a:t>
-            </a:r>
-          </a:p>
-        </p:txBody>
-      </p:sp>
-      <p:sp>
-        <p:nvSpPr>
-          <p:cNvPr id="23" name="TextBox 22"/>
-          <p:cNvSpPr txBox="1"/>
-          <p:nvPr/>
-        </p:nvSpPr>
-        <p:spPr>
-          <a:xfrm>
-            <a:off x="6232200" y="4434840"/>
-            <a:ext cx="5550000" cy="274320"/>
-          </a:xfrm>
-          <a:prstGeom prst="rect">
-            <a:avLst/>
-          </a:prstGeom>
-          <a:noFill/>
-        </p:spPr>
-        <p:txBody>
-          <a:bodyPr wrap="square">
-            <a:spAutoFit/>
-          </a:bodyPr>
-          <a:lstStyle/>
-          <a:p>
-            <a:pPr algn="ctr">
-              <a:spcAft>
-                <a:spcPts val="0"/>
-              </a:spcAft>
-              <a:defRPr sz="1100" b="1">
-                <a:solidFill>
-                  <a:srgbClr val="0099D6"/>
-                </a:solidFill>
-                <a:latin typeface="Calibri"/>
-              </a:defRPr>
-            </a:pPr>
-            <a:r>
-              <a:t>REPO 2: product-pipeline</a:t>
-            </a:r>
-          </a:p>
-        </p:txBody>
-      </p:sp>
-      <p:sp>
-        <p:nvSpPr>
           <p:cNvPr id="24" name="Rounded Rectangle 23"/>
           <p:cNvSpPr/>
           <p:nvPr/>
         </p:nvSpPr>
         <p:spPr>
           <a:xfrm>
-            <a:off x="1371600" y="4880640"/>
+            <a:off x="1371600" y="5020000"/>
             <a:ext cx="9144000" cy="1768320"/>
           </a:xfrm>
           <a:prstGeom prst="roundRect">
@@ -9645,7 +9567,7 @@
         </p:nvSpPr>
         <p:spPr>
           <a:xfrm>
-            <a:off x="1645920" y="4972080"/>
+            <a:off x="1645920" y="5111440"/>
             <a:ext cx="8595360" cy="1584000"/>
           </a:xfrm>
           <a:prstGeom prst="rect">
@@ -10425,6 +10347,134 @@
             </a:pPr>
             <a:r>
               <a:t>3 / 10</a:t>
+            </a:r>
+          </a:p>
+        </p:txBody>
+      </p:sp>
+      <p:sp>
+        <p:nvSpPr>
+          <p:cNvPr id="700" name="RepoBar 700"/>
+          <p:cNvSpPr/>
+          <p:nvPr/>
+        </p:nvSpPr>
+        <p:spPr>
+          <a:xfrm>
+            <a:off x="457200" y="4530000"/>
+            <a:ext cx="5500000" cy="380000"/>
+          </a:xfrm>
+          <a:prstGeom prst="roundRect">
+            <a:avLst>
+              <a:gd name="adj" fmla="val 8000"/>
+            </a:avLst>
+          </a:prstGeom>
+          <a:solidFill>
+            <a:srgbClr val="003057"/>
+          </a:solidFill>
+          <a:ln>
+            <a:noFill/>
+          </a:ln>
+        </p:spPr>
+        <p:style>
+          <a:lnRef idx="1">
+            <a:schemeClr val="accent1"/>
+          </a:lnRef>
+          <a:fillRef idx="3">
+            <a:schemeClr val="accent1"/>
+          </a:fillRef>
+          <a:effectRef idx="2">
+            <a:schemeClr val="accent1"/>
+          </a:effectRef>
+          <a:fontRef idx="minor">
+            <a:schemeClr val="lt1"/>
+          </a:fontRef>
+        </p:style>
+        <p:txBody>
+          <a:bodyPr rtlCol="0" anchor="ctr" wrap="square"/>
+          <a:lstStyle/>
+          <a:p>
+            <a:pPr algn="ctr">
+              <a:defRPr sz="1100" b="1">
+                <a:solidFill>
+                  <a:srgbClr val="FFFFFF"/>
+                </a:solidFill>
+                <a:latin typeface="Calibri"/>
+              </a:defRPr>
+            </a:pPr>
+            <a:r>
+              <a:t xml:space="preserve">MODEL PIPELINE  </a:t>
+            </a:r>
+            <a:r>
+              <a:rPr sz="1100" b="0">
+                <a:solidFill>
+                  <a:srgbClr val="D0E8F8"/>
+                </a:solidFill>
+                <a:latin typeface="Calibri"/>
+              </a:rPr>
+              <a:t>cameo-model-pipeline</a:t>
+            </a:r>
+          </a:p>
+        </p:txBody>
+      </p:sp>
+      <p:sp>
+        <p:nvSpPr>
+          <p:cNvPr id="701" name="RepoBar 701"/>
+          <p:cNvSpPr/>
+          <p:nvPr/>
+        </p:nvSpPr>
+        <p:spPr>
+          <a:xfrm>
+            <a:off x="6232200" y="4530000"/>
+            <a:ext cx="5500000" cy="380000"/>
+          </a:xfrm>
+          <a:prstGeom prst="roundRect">
+            <a:avLst>
+              <a:gd name="adj" fmla="val 8000"/>
+            </a:avLst>
+          </a:prstGeom>
+          <a:solidFill>
+            <a:srgbClr val="0082CC"/>
+          </a:solidFill>
+          <a:ln>
+            <a:noFill/>
+          </a:ln>
+        </p:spPr>
+        <p:style>
+          <a:lnRef idx="1">
+            <a:schemeClr val="accent1"/>
+          </a:lnRef>
+          <a:fillRef idx="3">
+            <a:schemeClr val="accent1"/>
+          </a:fillRef>
+          <a:effectRef idx="2">
+            <a:schemeClr val="accent1"/>
+          </a:effectRef>
+          <a:fontRef idx="minor">
+            <a:schemeClr val="lt1"/>
+          </a:fontRef>
+        </p:style>
+        <p:txBody>
+          <a:bodyPr rtlCol="0" anchor="ctr" wrap="square"/>
+          <a:lstStyle/>
+          <a:p>
+            <a:pPr algn="ctr">
+              <a:defRPr sz="1100" b="1">
+                <a:solidFill>
+                  <a:srgbClr val="FFFFFF"/>
+                </a:solidFill>
+                <a:latin typeface="Calibri"/>
+              </a:defRPr>
+            </a:pPr>
+            <a:r>
+              <a:t xml:space="preserve">PRODUCT PIPELINE  </a:t>
+            </a:r>
+            <a:r>
+              <a:rPr sz="1100" b="0">
+                <a:solidFill>
+                  <a:srgbClr val="D0E8F8"/>
+                </a:solidFill>
+                <a:latin typeface="Calibri"/>
+              </a:rPr>
+              <a:t>product-pipeline</a:t>
             </a:r>
           </a:p>
         </p:txBody>

</xml_diff>